<commit_message>
Update DAIS project: data, outputs, and engine improvements
</commit_message>
<xml_diff>
--- a/outputs/DAIS_Deliverables/DAIS_Performance_Executive_Deck.pptx
+++ b/outputs/DAIS_Deliverables/DAIS_Performance_Executive_Deck.pptx
@@ -5,15 +5,14 @@
     <p:sldMasterId id="2147483648" r:id="rId1"/>
   </p:sldMasterIdLst>
   <p:sldIdLst>
-    <p:sldId id="256" r:id="rId2"/>
-    <p:sldId id="257" r:id="rId3"/>
-    <p:sldId id="258" r:id="rId4"/>
-    <p:sldId id="259" r:id="rId5"/>
-    <p:sldId id="260" r:id="rId6"/>
-    <p:sldId id="261" r:id="rId7"/>
-    <p:sldId id="262" r:id="rId8"/>
+    <p:sldId id="256" r:id="rId7"/>
+    <p:sldId id="257" r:id="rId8"/>
+    <p:sldId id="258" r:id="rId9"/>
+    <p:sldId id="259" r:id="rId10"/>
+    <p:sldId id="260" r:id="rId11"/>
+    <p:sldId id="261" r:id="rId12"/>
   </p:sldIdLst>
-  <p:sldSz cx="12192000" cy="6858000"/>
+  <p:sldSz cx="12191695" cy="6858000" type="screen4x3"/>
   <p:notesSz cx="6858000" cy="9144000"/>
   <p:defaultTextStyle>
     <a:defPPr>
@@ -110,52 +109,7 @@
       </a:defRPr>
     </a:lvl9pPr>
   </p:defaultTextStyle>
-  <p:extLst>
-    <p:ext uri="{EFAFB233-063F-42B5-8137-9DF3F51BA10A}">
-      <p15:sldGuideLst xmlns:p15="http://schemas.microsoft.com/office/powerpoint/2012/main">
-        <p15:guide id="1" orient="horz" pos="2160">
-          <p15:clr>
-            <a:srgbClr val="A4A3A4"/>
-          </p15:clr>
-        </p15:guide>
-        <p15:guide id="2" pos="2880">
-          <p15:clr>
-            <a:srgbClr val="A4A3A4"/>
-          </p15:clr>
-        </p15:guide>
-      </p15:sldGuideLst>
-    </p:ext>
-  </p:extLst>
 </p:presentation>
-</file>
-
-<file path=ppt/changesInfos/changesInfo1.xml><?xml version="1.0" encoding="utf-8"?>
-<pc:chgInfo xmlns:a="http://schemas.openxmlformats.org/drawingml/2006/main" xmlns:r="http://schemas.openxmlformats.org/officeDocument/2006/relationships" xmlns:ac="http://schemas.microsoft.com/office/drawing/2013/main/command" xmlns:pc="http://schemas.microsoft.com/office/powerpoint/2013/main/command">
-  <pc:docChgLst>
-    <pc:chgData name="Darryl O'Mara" userId="c246bccc-ec1e-4de2-ba64-3449d8315139" providerId="ADAL" clId="{A44B3D7E-E539-4818-8DCD-643CF3D3CFA3}"/>
-    <pc:docChg chg="modSld">
-      <pc:chgData name="Darryl O'Mara" userId="c246bccc-ec1e-4de2-ba64-3449d8315139" providerId="ADAL" clId="{A44B3D7E-E539-4818-8DCD-643CF3D3CFA3}" dt="2026-06-11T03:57:29.344" v="0" actId="1036"/>
-      <pc:docMkLst>
-        <pc:docMk/>
-      </pc:docMkLst>
-      <pc:sldChg chg="modSp mod">
-        <pc:chgData name="Darryl O'Mara" userId="c246bccc-ec1e-4de2-ba64-3449d8315139" providerId="ADAL" clId="{A44B3D7E-E539-4818-8DCD-643CF3D3CFA3}" dt="2026-06-11T03:57:29.344" v="0" actId="1036"/>
-        <pc:sldMkLst>
-          <pc:docMk/>
-          <pc:sldMk cId="0" sldId="256"/>
-        </pc:sldMkLst>
-        <pc:spChg chg="mod">
-          <ac:chgData name="Darryl O'Mara" userId="c246bccc-ec1e-4de2-ba64-3449d8315139" providerId="ADAL" clId="{A44B3D7E-E539-4818-8DCD-643CF3D3CFA3}" dt="2026-06-11T03:57:29.344" v="0" actId="1036"/>
-          <ac:spMkLst>
-            <pc:docMk/>
-            <pc:sldMk cId="0" sldId="256"/>
-            <ac:spMk id="2" creationId="{00000000-0000-0000-0000-000000000000}"/>
-          </ac:spMkLst>
-        </pc:spChg>
-      </pc:sldChg>
-    </pc:docChg>
-  </pc:docChgLst>
-</pc:chgInfo>
 </file>
 
 <file path=ppt/slideLayouts/slideLayout1.xml><?xml version="1.0" encoding="utf-8"?>
@@ -196,9 +150,10 @@
           <a:lstStyle/>
           <a:p>
             <a:r>
-              <a:rPr lang="en-US"/>
+              <a:rPr lang="en-US" smtClean="0"/>
               <a:t>Click to edit Master title style</a:t>
             </a:r>
+            <a:endParaRPr lang="en-US"/>
           </a:p>
         </p:txBody>
       </p:sp>
@@ -314,9 +269,10 @@
           </a:lstStyle>
           <a:p>
             <a:r>
-              <a:rPr lang="en-US"/>
+              <a:rPr lang="en-US" smtClean="0"/>
               <a:t>Click to edit Master subtitle style</a:t>
             </a:r>
+            <a:endParaRPr lang="en-US"/>
           </a:p>
         </p:txBody>
       </p:sp>
@@ -337,7 +293,7 @@
           <a:p>
             <a:fld id="{5BCAD085-E8A6-8845-BD4E-CB4CCA059FC4}" type="datetimeFigureOut">
               <a:rPr lang="en-US" smtClean="0"/>
-              <a:t>6/10/2026</a:t>
+              <a:t>1/27/13</a:t>
             </a:fld>
             <a:endParaRPr lang="en-US"/>
           </a:p>
@@ -431,9 +387,10 @@
           <a:lstStyle/>
           <a:p>
             <a:r>
-              <a:rPr lang="en-US"/>
+              <a:rPr lang="en-US" smtClean="0"/>
               <a:t>Click to edit Master title style</a:t>
             </a:r>
+            <a:endParaRPr lang="en-US"/>
           </a:p>
         </p:txBody>
       </p:sp>
@@ -454,37 +411,38 @@
           <a:p>
             <a:pPr lvl="0"/>
             <a:r>
-              <a:rPr lang="en-US"/>
+              <a:rPr lang="en-US" smtClean="0"/>
               <a:t>Click to edit Master text styles</a:t>
             </a:r>
           </a:p>
           <a:p>
             <a:pPr lvl="1"/>
             <a:r>
-              <a:rPr lang="en-US"/>
+              <a:rPr lang="en-US" smtClean="0"/>
               <a:t>Second level</a:t>
             </a:r>
           </a:p>
           <a:p>
             <a:pPr lvl="2"/>
             <a:r>
-              <a:rPr lang="en-US"/>
+              <a:rPr lang="en-US" smtClean="0"/>
               <a:t>Third level</a:t>
             </a:r>
           </a:p>
           <a:p>
             <a:pPr lvl="3"/>
             <a:r>
-              <a:rPr lang="en-US"/>
+              <a:rPr lang="en-US" smtClean="0"/>
               <a:t>Fourth level</a:t>
             </a:r>
           </a:p>
           <a:p>
             <a:pPr lvl="4"/>
             <a:r>
-              <a:rPr lang="en-US"/>
+              <a:rPr lang="en-US" smtClean="0"/>
               <a:t>Fifth level</a:t>
             </a:r>
+            <a:endParaRPr lang="en-US"/>
           </a:p>
         </p:txBody>
       </p:sp>
@@ -505,7 +463,7 @@
           <a:p>
             <a:fld id="{5BCAD085-E8A6-8845-BD4E-CB4CCA059FC4}" type="datetimeFigureOut">
               <a:rPr lang="en-US" smtClean="0"/>
-              <a:t>6/10/2026</a:t>
+              <a:t>1/27/13</a:t>
             </a:fld>
             <a:endParaRPr lang="en-US"/>
           </a:p>
@@ -604,9 +562,10 @@
           <a:lstStyle/>
           <a:p>
             <a:r>
-              <a:rPr lang="en-US"/>
+              <a:rPr lang="en-US" smtClean="0"/>
               <a:t>Click to edit Master title style</a:t>
             </a:r>
+            <a:endParaRPr lang="en-US"/>
           </a:p>
         </p:txBody>
       </p:sp>
@@ -632,37 +591,38 @@
           <a:p>
             <a:pPr lvl="0"/>
             <a:r>
-              <a:rPr lang="en-US"/>
+              <a:rPr lang="en-US" smtClean="0"/>
               <a:t>Click to edit Master text styles</a:t>
             </a:r>
           </a:p>
           <a:p>
             <a:pPr lvl="1"/>
             <a:r>
-              <a:rPr lang="en-US"/>
+              <a:rPr lang="en-US" smtClean="0"/>
               <a:t>Second level</a:t>
             </a:r>
           </a:p>
           <a:p>
             <a:pPr lvl="2"/>
             <a:r>
-              <a:rPr lang="en-US"/>
+              <a:rPr lang="en-US" smtClean="0"/>
               <a:t>Third level</a:t>
             </a:r>
           </a:p>
           <a:p>
             <a:pPr lvl="3"/>
             <a:r>
-              <a:rPr lang="en-US"/>
+              <a:rPr lang="en-US" smtClean="0"/>
               <a:t>Fourth level</a:t>
             </a:r>
           </a:p>
           <a:p>
             <a:pPr lvl="4"/>
             <a:r>
-              <a:rPr lang="en-US"/>
+              <a:rPr lang="en-US" smtClean="0"/>
               <a:t>Fifth level</a:t>
             </a:r>
+            <a:endParaRPr lang="en-US"/>
           </a:p>
         </p:txBody>
       </p:sp>
@@ -683,7 +643,7 @@
           <a:p>
             <a:fld id="{5BCAD085-E8A6-8845-BD4E-CB4CCA059FC4}" type="datetimeFigureOut">
               <a:rPr lang="en-US" smtClean="0"/>
-              <a:t>6/10/2026</a:t>
+              <a:t>1/27/13</a:t>
             </a:fld>
             <a:endParaRPr lang="en-US"/>
           </a:p>
@@ -777,9 +737,10 @@
           <a:lstStyle/>
           <a:p>
             <a:r>
-              <a:rPr lang="en-US"/>
+              <a:rPr lang="en-US" smtClean="0"/>
               <a:t>Click to edit Master title style</a:t>
             </a:r>
+            <a:endParaRPr lang="en-US"/>
           </a:p>
         </p:txBody>
       </p:sp>
@@ -800,37 +761,38 @@
           <a:p>
             <a:pPr lvl="0"/>
             <a:r>
-              <a:rPr lang="en-US"/>
+              <a:rPr lang="en-US" smtClean="0"/>
               <a:t>Click to edit Master text styles</a:t>
             </a:r>
           </a:p>
           <a:p>
             <a:pPr lvl="1"/>
             <a:r>
-              <a:rPr lang="en-US"/>
+              <a:rPr lang="en-US" smtClean="0"/>
               <a:t>Second level</a:t>
             </a:r>
           </a:p>
           <a:p>
             <a:pPr lvl="2"/>
             <a:r>
-              <a:rPr lang="en-US"/>
+              <a:rPr lang="en-US" smtClean="0"/>
               <a:t>Third level</a:t>
             </a:r>
           </a:p>
           <a:p>
             <a:pPr lvl="3"/>
             <a:r>
-              <a:rPr lang="en-US"/>
+              <a:rPr lang="en-US" smtClean="0"/>
               <a:t>Fourth level</a:t>
             </a:r>
           </a:p>
           <a:p>
             <a:pPr lvl="4"/>
             <a:r>
-              <a:rPr lang="en-US"/>
+              <a:rPr lang="en-US" smtClean="0"/>
               <a:t>Fifth level</a:t>
             </a:r>
+            <a:endParaRPr lang="en-US"/>
           </a:p>
         </p:txBody>
       </p:sp>
@@ -851,7 +813,7 @@
           <a:p>
             <a:fld id="{5BCAD085-E8A6-8845-BD4E-CB4CCA059FC4}" type="datetimeFigureOut">
               <a:rPr lang="en-US" smtClean="0"/>
-              <a:t>6/10/2026</a:t>
+              <a:t>1/27/13</a:t>
             </a:fld>
             <a:endParaRPr lang="en-US"/>
           </a:p>
@@ -954,9 +916,10 @@
           </a:lstStyle>
           <a:p>
             <a:r>
-              <a:rPr lang="en-US"/>
+              <a:rPr lang="en-US" smtClean="0"/>
               <a:t>Click to edit Master title style</a:t>
             </a:r>
+            <a:endParaRPr lang="en-US"/>
           </a:p>
         </p:txBody>
       </p:sp>
@@ -1073,7 +1036,7 @@
           <a:p>
             <a:pPr lvl="0"/>
             <a:r>
-              <a:rPr lang="en-US"/>
+              <a:rPr lang="en-US" smtClean="0"/>
               <a:t>Click to edit Master text styles</a:t>
             </a:r>
           </a:p>
@@ -1096,7 +1059,7 @@
           <a:p>
             <a:fld id="{5BCAD085-E8A6-8845-BD4E-CB4CCA059FC4}" type="datetimeFigureOut">
               <a:rPr lang="en-US" smtClean="0"/>
-              <a:t>6/10/2026</a:t>
+              <a:t>1/27/13</a:t>
             </a:fld>
             <a:endParaRPr lang="en-US"/>
           </a:p>
@@ -1190,9 +1153,10 @@
           <a:lstStyle/>
           <a:p>
             <a:r>
-              <a:rPr lang="en-US"/>
+              <a:rPr lang="en-US" smtClean="0"/>
               <a:t>Click to edit Master title style</a:t>
             </a:r>
+            <a:endParaRPr lang="en-US"/>
           </a:p>
         </p:txBody>
       </p:sp>
@@ -1246,37 +1210,38 @@
           <a:p>
             <a:pPr lvl="0"/>
             <a:r>
-              <a:rPr lang="en-US"/>
+              <a:rPr lang="en-US" smtClean="0"/>
               <a:t>Click to edit Master text styles</a:t>
             </a:r>
           </a:p>
           <a:p>
             <a:pPr lvl="1"/>
             <a:r>
-              <a:rPr lang="en-US"/>
+              <a:rPr lang="en-US" smtClean="0"/>
               <a:t>Second level</a:t>
             </a:r>
           </a:p>
           <a:p>
             <a:pPr lvl="2"/>
             <a:r>
-              <a:rPr lang="en-US"/>
+              <a:rPr lang="en-US" smtClean="0"/>
               <a:t>Third level</a:t>
             </a:r>
           </a:p>
           <a:p>
             <a:pPr lvl="3"/>
             <a:r>
-              <a:rPr lang="en-US"/>
+              <a:rPr lang="en-US" smtClean="0"/>
               <a:t>Fourth level</a:t>
             </a:r>
           </a:p>
           <a:p>
             <a:pPr lvl="4"/>
             <a:r>
-              <a:rPr lang="en-US"/>
+              <a:rPr lang="en-US" smtClean="0"/>
               <a:t>Fifth level</a:t>
             </a:r>
+            <a:endParaRPr lang="en-US"/>
           </a:p>
         </p:txBody>
       </p:sp>
@@ -1330,37 +1295,38 @@
           <a:p>
             <a:pPr lvl="0"/>
             <a:r>
-              <a:rPr lang="en-US"/>
+              <a:rPr lang="en-US" smtClean="0"/>
               <a:t>Click to edit Master text styles</a:t>
             </a:r>
           </a:p>
           <a:p>
             <a:pPr lvl="1"/>
             <a:r>
-              <a:rPr lang="en-US"/>
+              <a:rPr lang="en-US" smtClean="0"/>
               <a:t>Second level</a:t>
             </a:r>
           </a:p>
           <a:p>
             <a:pPr lvl="2"/>
             <a:r>
-              <a:rPr lang="en-US"/>
+              <a:rPr lang="en-US" smtClean="0"/>
               <a:t>Third level</a:t>
             </a:r>
           </a:p>
           <a:p>
             <a:pPr lvl="3"/>
             <a:r>
-              <a:rPr lang="en-US"/>
+              <a:rPr lang="en-US" smtClean="0"/>
               <a:t>Fourth level</a:t>
             </a:r>
           </a:p>
           <a:p>
             <a:pPr lvl="4"/>
             <a:r>
-              <a:rPr lang="en-US"/>
+              <a:rPr lang="en-US" smtClean="0"/>
               <a:t>Fifth level</a:t>
             </a:r>
+            <a:endParaRPr lang="en-US"/>
           </a:p>
         </p:txBody>
       </p:sp>
@@ -1381,7 +1347,7 @@
           <a:p>
             <a:fld id="{5BCAD085-E8A6-8845-BD4E-CB4CCA059FC4}" type="datetimeFigureOut">
               <a:rPr lang="en-US" smtClean="0"/>
-              <a:t>6/10/2026</a:t>
+              <a:t>1/27/13</a:t>
             </a:fld>
             <a:endParaRPr lang="en-US"/>
           </a:p>
@@ -1479,9 +1445,10 @@
           </a:lstStyle>
           <a:p>
             <a:r>
-              <a:rPr lang="en-US"/>
+              <a:rPr lang="en-US" smtClean="0"/>
               <a:t>Click to edit Master title style</a:t>
             </a:r>
+            <a:endParaRPr lang="en-US"/>
           </a:p>
         </p:txBody>
       </p:sp>
@@ -1544,7 +1511,7 @@
           <a:p>
             <a:pPr lvl="0"/>
             <a:r>
-              <a:rPr lang="en-US"/>
+              <a:rPr lang="en-US" smtClean="0"/>
               <a:t>Click to edit Master text styles</a:t>
             </a:r>
           </a:p>
@@ -1600,37 +1567,38 @@
           <a:p>
             <a:pPr lvl="0"/>
             <a:r>
-              <a:rPr lang="en-US"/>
+              <a:rPr lang="en-US" smtClean="0"/>
               <a:t>Click to edit Master text styles</a:t>
             </a:r>
           </a:p>
           <a:p>
             <a:pPr lvl="1"/>
             <a:r>
-              <a:rPr lang="en-US"/>
+              <a:rPr lang="en-US" smtClean="0"/>
               <a:t>Second level</a:t>
             </a:r>
           </a:p>
           <a:p>
             <a:pPr lvl="2"/>
             <a:r>
-              <a:rPr lang="en-US"/>
+              <a:rPr lang="en-US" smtClean="0"/>
               <a:t>Third level</a:t>
             </a:r>
           </a:p>
           <a:p>
             <a:pPr lvl="3"/>
             <a:r>
-              <a:rPr lang="en-US"/>
+              <a:rPr lang="en-US" smtClean="0"/>
               <a:t>Fourth level</a:t>
             </a:r>
           </a:p>
           <a:p>
             <a:pPr lvl="4"/>
             <a:r>
-              <a:rPr lang="en-US"/>
+              <a:rPr lang="en-US" smtClean="0"/>
               <a:t>Fifth level</a:t>
             </a:r>
+            <a:endParaRPr lang="en-US"/>
           </a:p>
         </p:txBody>
       </p:sp>
@@ -1693,7 +1661,7 @@
           <a:p>
             <a:pPr lvl="0"/>
             <a:r>
-              <a:rPr lang="en-US"/>
+              <a:rPr lang="en-US" smtClean="0"/>
               <a:t>Click to edit Master text styles</a:t>
             </a:r>
           </a:p>
@@ -1749,37 +1717,38 @@
           <a:p>
             <a:pPr lvl="0"/>
             <a:r>
-              <a:rPr lang="en-US"/>
+              <a:rPr lang="en-US" smtClean="0"/>
               <a:t>Click to edit Master text styles</a:t>
             </a:r>
           </a:p>
           <a:p>
             <a:pPr lvl="1"/>
             <a:r>
-              <a:rPr lang="en-US"/>
+              <a:rPr lang="en-US" smtClean="0"/>
               <a:t>Second level</a:t>
             </a:r>
           </a:p>
           <a:p>
             <a:pPr lvl="2"/>
             <a:r>
-              <a:rPr lang="en-US"/>
+              <a:rPr lang="en-US" smtClean="0"/>
               <a:t>Third level</a:t>
             </a:r>
           </a:p>
           <a:p>
             <a:pPr lvl="3"/>
             <a:r>
-              <a:rPr lang="en-US"/>
+              <a:rPr lang="en-US" smtClean="0"/>
               <a:t>Fourth level</a:t>
             </a:r>
           </a:p>
           <a:p>
             <a:pPr lvl="4"/>
             <a:r>
-              <a:rPr lang="en-US"/>
+              <a:rPr lang="en-US" smtClean="0"/>
               <a:t>Fifth level</a:t>
             </a:r>
+            <a:endParaRPr lang="en-US"/>
           </a:p>
         </p:txBody>
       </p:sp>
@@ -1800,7 +1769,7 @@
           <a:p>
             <a:fld id="{5BCAD085-E8A6-8845-BD4E-CB4CCA059FC4}" type="datetimeFigureOut">
               <a:rPr lang="en-US" smtClean="0"/>
-              <a:t>6/10/2026</a:t>
+              <a:t>1/27/13</a:t>
             </a:fld>
             <a:endParaRPr lang="en-US"/>
           </a:p>
@@ -1894,9 +1863,10 @@
           <a:lstStyle/>
           <a:p>
             <a:r>
-              <a:rPr lang="en-US"/>
+              <a:rPr lang="en-US" smtClean="0"/>
               <a:t>Click to edit Master title style</a:t>
             </a:r>
+            <a:endParaRPr lang="en-US"/>
           </a:p>
         </p:txBody>
       </p:sp>
@@ -1917,7 +1887,7 @@
           <a:p>
             <a:fld id="{5BCAD085-E8A6-8845-BD4E-CB4CCA059FC4}" type="datetimeFigureOut">
               <a:rPr lang="en-US" smtClean="0"/>
-              <a:t>6/10/2026</a:t>
+              <a:t>1/27/13</a:t>
             </a:fld>
             <a:endParaRPr lang="en-US"/>
           </a:p>
@@ -2012,7 +1982,7 @@
           <a:p>
             <a:fld id="{5BCAD085-E8A6-8845-BD4E-CB4CCA059FC4}" type="datetimeFigureOut">
               <a:rPr lang="en-US" smtClean="0"/>
-              <a:t>6/10/2026</a:t>
+              <a:t>1/27/13</a:t>
             </a:fld>
             <a:endParaRPr lang="en-US"/>
           </a:p>
@@ -2115,9 +2085,10 @@
           </a:lstStyle>
           <a:p>
             <a:r>
-              <a:rPr lang="en-US"/>
+              <a:rPr lang="en-US" smtClean="0"/>
               <a:t>Click to edit Master title style</a:t>
             </a:r>
+            <a:endParaRPr lang="en-US"/>
           </a:p>
         </p:txBody>
       </p:sp>
@@ -2171,37 +2142,38 @@
           <a:p>
             <a:pPr lvl="0"/>
             <a:r>
-              <a:rPr lang="en-US"/>
+              <a:rPr lang="en-US" smtClean="0"/>
               <a:t>Click to edit Master text styles</a:t>
             </a:r>
           </a:p>
           <a:p>
             <a:pPr lvl="1"/>
             <a:r>
-              <a:rPr lang="en-US"/>
+              <a:rPr lang="en-US" smtClean="0"/>
               <a:t>Second level</a:t>
             </a:r>
           </a:p>
           <a:p>
             <a:pPr lvl="2"/>
             <a:r>
-              <a:rPr lang="en-US"/>
+              <a:rPr lang="en-US" smtClean="0"/>
               <a:t>Third level</a:t>
             </a:r>
           </a:p>
           <a:p>
             <a:pPr lvl="3"/>
             <a:r>
-              <a:rPr lang="en-US"/>
+              <a:rPr lang="en-US" smtClean="0"/>
               <a:t>Fourth level</a:t>
             </a:r>
           </a:p>
           <a:p>
             <a:pPr lvl="4"/>
             <a:r>
-              <a:rPr lang="en-US"/>
+              <a:rPr lang="en-US" smtClean="0"/>
               <a:t>Fifth level</a:t>
             </a:r>
+            <a:endParaRPr lang="en-US"/>
           </a:p>
         </p:txBody>
       </p:sp>
@@ -2264,7 +2236,7 @@
           <a:p>
             <a:pPr lvl="0"/>
             <a:r>
-              <a:rPr lang="en-US"/>
+              <a:rPr lang="en-US" smtClean="0"/>
               <a:t>Click to edit Master text styles</a:t>
             </a:r>
           </a:p>
@@ -2287,7 +2259,7 @@
           <a:p>
             <a:fld id="{5BCAD085-E8A6-8845-BD4E-CB4CCA059FC4}" type="datetimeFigureOut">
               <a:rPr lang="en-US" smtClean="0"/>
-              <a:t>6/10/2026</a:t>
+              <a:t>1/27/13</a:t>
             </a:fld>
             <a:endParaRPr lang="en-US"/>
           </a:p>
@@ -2390,9 +2362,10 @@
           </a:lstStyle>
           <a:p>
             <a:r>
-              <a:rPr lang="en-US"/>
+              <a:rPr lang="en-US" smtClean="0"/>
               <a:t>Click to edit Master title style</a:t>
             </a:r>
+            <a:endParaRPr lang="en-US"/>
           </a:p>
         </p:txBody>
       </p:sp>
@@ -2516,7 +2489,7 @@
           <a:p>
             <a:pPr lvl="0"/>
             <a:r>
-              <a:rPr lang="en-US"/>
+              <a:rPr lang="en-US" smtClean="0"/>
               <a:t>Click to edit Master text styles</a:t>
             </a:r>
           </a:p>
@@ -2539,7 +2512,7 @@
           <a:p>
             <a:fld id="{5BCAD085-E8A6-8845-BD4E-CB4CCA059FC4}" type="datetimeFigureOut">
               <a:rPr lang="en-US" smtClean="0"/>
-              <a:t>6/10/2026</a:t>
+              <a:t>1/27/13</a:t>
             </a:fld>
             <a:endParaRPr lang="en-US"/>
           </a:p>
@@ -2648,9 +2621,10 @@
           <a:lstStyle/>
           <a:p>
             <a:r>
-              <a:rPr lang="en-US"/>
+              <a:rPr lang="en-US" smtClean="0"/>
               <a:t>Click to edit Master title style</a:t>
             </a:r>
+            <a:endParaRPr lang="en-US"/>
           </a:p>
         </p:txBody>
       </p:sp>
@@ -2681,37 +2655,38 @@
           <a:p>
             <a:pPr lvl="0"/>
             <a:r>
-              <a:rPr lang="en-US"/>
+              <a:rPr lang="en-US" smtClean="0"/>
               <a:t>Click to edit Master text styles</a:t>
             </a:r>
           </a:p>
           <a:p>
             <a:pPr lvl="1"/>
             <a:r>
-              <a:rPr lang="en-US"/>
+              <a:rPr lang="en-US" smtClean="0"/>
               <a:t>Second level</a:t>
             </a:r>
           </a:p>
           <a:p>
             <a:pPr lvl="2"/>
             <a:r>
-              <a:rPr lang="en-US"/>
+              <a:rPr lang="en-US" smtClean="0"/>
               <a:t>Third level</a:t>
             </a:r>
           </a:p>
           <a:p>
             <a:pPr lvl="3"/>
             <a:r>
-              <a:rPr lang="en-US"/>
+              <a:rPr lang="en-US" smtClean="0"/>
               <a:t>Fourth level</a:t>
             </a:r>
           </a:p>
           <a:p>
             <a:pPr lvl="4"/>
             <a:r>
-              <a:rPr lang="en-US"/>
+              <a:rPr lang="en-US" smtClean="0"/>
               <a:t>Fifth level</a:t>
             </a:r>
+            <a:endParaRPr lang="en-US"/>
           </a:p>
         </p:txBody>
       </p:sp>
@@ -2750,7 +2725,7 @@
           <a:p>
             <a:fld id="{5BCAD085-E8A6-8845-BD4E-CB4CCA059FC4}" type="datetimeFigureOut">
               <a:rPr lang="en-US" smtClean="0"/>
-              <a:t>6/10/2026</a:t>
+              <a:t>1/27/13</a:t>
             </a:fld>
             <a:endParaRPr lang="en-US"/>
           </a:p>
@@ -3109,7 +3084,7 @@
 </file>
 
 <file path=ppt/slides/slide1.xml><?xml version="1.0" encoding="utf-8"?>
-<p:sld xmlns:a="http://schemas.openxmlformats.org/drawingml/2006/main" xmlns:r="http://schemas.openxmlformats.org/officeDocument/2006/relationships" xmlns:p="http://schemas.openxmlformats.org/presentationml/2006/main">
+<p:sld xmlns:a="http://schemas.openxmlformats.org/drawingml/2006/main" xmlns:p="http://schemas.openxmlformats.org/presentationml/2006/main" xmlns:r="http://schemas.openxmlformats.org/officeDocument/2006/relationships">
   <p:cSld>
     <p:spTree>
       <p:nvGrpSpPr>
@@ -3117,14 +3092,7 @@
         <p:cNvGrpSpPr/>
         <p:nvPr/>
       </p:nvGrpSpPr>
-      <p:grpSpPr>
-        <a:xfrm>
-          <a:off x="0" y="0"/>
-          <a:ext cx="0" cy="0"/>
-          <a:chOff x="0" y="0"/>
-          <a:chExt cx="0" cy="0"/>
-        </a:xfrm>
-      </p:grpSpPr>
+      <p:grpSpPr/>
       <p:sp>
         <p:nvSpPr>
           <p:cNvPr id="2" name="Rectangle 1"/>
@@ -3133,7 +3101,7 @@
         </p:nvSpPr>
         <p:spPr>
           <a:xfrm>
-            <a:off x="0" y="10633"/>
+            <a:off x="0" y="0"/>
             <a:ext cx="12191695" cy="6858000"/>
           </a:xfrm>
           <a:prstGeom prst="rect">
@@ -3165,7 +3133,6 @@
           <a:lstStyle/>
           <a:p>
             <a:pPr algn="ctr"/>
-            <a:endParaRPr/>
           </a:p>
         </p:txBody>
       </p:sp>
@@ -3230,7 +3197,7 @@
 </file>
 
 <file path=ppt/slides/slide2.xml><?xml version="1.0" encoding="utf-8"?>
-<p:sld xmlns:a="http://schemas.openxmlformats.org/drawingml/2006/main" xmlns:r="http://schemas.openxmlformats.org/officeDocument/2006/relationships" xmlns:p="http://schemas.openxmlformats.org/presentationml/2006/main">
+<p:sld xmlns:a="http://schemas.openxmlformats.org/drawingml/2006/main" xmlns:p="http://schemas.openxmlformats.org/presentationml/2006/main" xmlns:r="http://schemas.openxmlformats.org/officeDocument/2006/relationships">
   <p:cSld>
     <p:spTree>
       <p:nvGrpSpPr>
@@ -3238,14 +3205,7 @@
         <p:cNvGrpSpPr/>
         <p:nvPr/>
       </p:nvGrpSpPr>
-      <p:grpSpPr>
-        <a:xfrm>
-          <a:off x="0" y="0"/>
-          <a:ext cx="0" cy="0"/>
-          <a:chOff x="0" y="0"/>
-          <a:chExt cx="0" cy="0"/>
-        </a:xfrm>
-      </p:grpSpPr>
+      <p:grpSpPr/>
       <p:sp>
         <p:nvSpPr>
           <p:cNvPr id="2" name="TextBox 1"/>
@@ -3291,7 +3251,7 @@
         </p:nvGraphicFramePr>
         <p:xfrm>
           <a:off x="685800" y="1371600"/>
-          <a:ext cx="10820095" cy="2194560"/>
+          <a:ext cx="10820095" cy="1828800"/>
         </p:xfrm>
         <a:graphic>
           <a:graphicData uri="http://schemas.openxmlformats.org/drawingml/2006/table">
@@ -3300,48 +3260,12 @@
                 <a:tableStyleId>{5C22544A-7EE6-4342-B048-85BDC9FD1C3A}</a:tableStyleId>
               </a:tblPr>
               <a:tblGrid>
-                <a:gridCol w="1676095">
-                  <a:extLst>
-                    <a:ext uri="{9D8B030D-6E8A-4147-A177-3AD203B41FA5}">
-                      <a16:colId xmlns:a16="http://schemas.microsoft.com/office/drawing/2014/main" val="20000"/>
-                    </a:ext>
-                  </a:extLst>
-                </a:gridCol>
-                <a:gridCol w="1828800">
-                  <a:extLst>
-                    <a:ext uri="{9D8B030D-6E8A-4147-A177-3AD203B41FA5}">
-                      <a16:colId xmlns:a16="http://schemas.microsoft.com/office/drawing/2014/main" val="20001"/>
-                    </a:ext>
-                  </a:extLst>
-                </a:gridCol>
-                <a:gridCol w="1828800">
-                  <a:extLst>
-                    <a:ext uri="{9D8B030D-6E8A-4147-A177-3AD203B41FA5}">
-                      <a16:colId xmlns:a16="http://schemas.microsoft.com/office/drawing/2014/main" val="20002"/>
-                    </a:ext>
-                  </a:extLst>
-                </a:gridCol>
-                <a:gridCol w="1828800">
-                  <a:extLst>
-                    <a:ext uri="{9D8B030D-6E8A-4147-A177-3AD203B41FA5}">
-                      <a16:colId xmlns:a16="http://schemas.microsoft.com/office/drawing/2014/main" val="20003"/>
-                    </a:ext>
-                  </a:extLst>
-                </a:gridCol>
-                <a:gridCol w="1828800">
-                  <a:extLst>
-                    <a:ext uri="{9D8B030D-6E8A-4147-A177-3AD203B41FA5}">
-                      <a16:colId xmlns:a16="http://schemas.microsoft.com/office/drawing/2014/main" val="20004"/>
-                    </a:ext>
-                  </a:extLst>
-                </a:gridCol>
-                <a:gridCol w="1828800">
-                  <a:extLst>
-                    <a:ext uri="{9D8B030D-6E8A-4147-A177-3AD203B41FA5}">
-                      <a16:colId xmlns:a16="http://schemas.microsoft.com/office/drawing/2014/main" val="20005"/>
-                    </a:ext>
-                  </a:extLst>
-                </a:gridCol>
+                <a:gridCol w="1676095"/>
+                <a:gridCol w="1828800"/>
+                <a:gridCol w="1828800"/>
+                <a:gridCol w="1828800"/>
+                <a:gridCol w="1828800"/>
+                <a:gridCol w="1828800"/>
               </a:tblGrid>
               <a:tr h="365760">
                 <a:tc>
@@ -3482,11 +3406,6 @@
                     </a:solidFill>
                   </a:tcPr>
                 </a:tc>
-                <a:extLst>
-                  <a:ext uri="{0D108BD9-81ED-4DB2-BD59-A6C34878D82A}">
-                    <a16:rowId xmlns:a16="http://schemas.microsoft.com/office/drawing/2014/main" val="10000"/>
-                  </a:ext>
-                </a:extLst>
               </a:tr>
               <a:tr h="365760">
                 <a:tc>
@@ -3502,7 +3421,7 @@
                         </a:defRPr>
                       </a:pPr>
                       <a:r>
-                        <a:t>META</a:t>
+                        <a:t>CMCI</a:t>
                       </a:r>
                     </a:p>
                   </a:txBody>
@@ -3597,17 +3516,12 @@
                         </a:defRPr>
                       </a:pPr>
                       <a:r>
-                        <a:t>0.43</a:t>
+                        <a:t>N/A</a:t>
                       </a:r>
                     </a:p>
                   </a:txBody>
                   <a:tcPr/>
                 </a:tc>
-                <a:extLst>
-                  <a:ext uri="{0D108BD9-81ED-4DB2-BD59-A6C34878D82A}">
-                    <a16:rowId xmlns:a16="http://schemas.microsoft.com/office/drawing/2014/main" val="10001"/>
-                  </a:ext>
-                </a:extLst>
               </a:tr>
               <a:tr h="365760">
                 <a:tc>
@@ -3623,7 +3537,7 @@
                         </a:defRPr>
                       </a:pPr>
                       <a:r>
-                        <a:t>SOXX</a:t>
+                        <a:t>BGLD</a:t>
                       </a:r>
                     </a:p>
                   </a:txBody>
@@ -3718,17 +3632,12 @@
                         </a:defRPr>
                       </a:pPr>
                       <a:r>
-                        <a:t>2.55</a:t>
+                        <a:t>0.24</a:t>
                       </a:r>
                     </a:p>
                   </a:txBody>
                   <a:tcPr/>
                 </a:tc>
-                <a:extLst>
-                  <a:ext uri="{0D108BD9-81ED-4DB2-BD59-A6C34878D82A}">
-                    <a16:rowId xmlns:a16="http://schemas.microsoft.com/office/drawing/2014/main" val="10002"/>
-                  </a:ext>
-                </a:extLst>
               </a:tr>
               <a:tr h="365760">
                 <a:tc>
@@ -3744,7 +3653,7 @@
                         </a:defRPr>
                       </a:pPr>
                       <a:r>
-                        <a:t>STT</a:t>
+                        <a:t>JEPQ</a:t>
                       </a:r>
                     </a:p>
                   </a:txBody>
@@ -3839,17 +3748,12 @@
                         </a:defRPr>
                       </a:pPr>
                       <a:r>
-                        <a:t>0.48</a:t>
+                        <a:t>0.61</a:t>
                       </a:r>
                     </a:p>
                   </a:txBody>
                   <a:tcPr/>
                 </a:tc>
-                <a:extLst>
-                  <a:ext uri="{0D108BD9-81ED-4DB2-BD59-A6C34878D82A}">
-                    <a16:rowId xmlns:a16="http://schemas.microsoft.com/office/drawing/2014/main" val="10003"/>
-                  </a:ext>
-                </a:extLst>
               </a:tr>
               <a:tr h="365760">
                 <a:tc>
@@ -3865,7 +3769,7 @@
                         </a:defRPr>
                       </a:pPr>
                       <a:r>
-                        <a:t>MSFT</a:t>
+                        <a:t>QQQI</a:t>
                       </a:r>
                     </a:p>
                   </a:txBody>
@@ -3960,138 +3864,12 @@
                         </a:defRPr>
                       </a:pPr>
                       <a:r>
-                        <a:t>0.39</a:t>
+                        <a:t>0.84</a:t>
                       </a:r>
                     </a:p>
                   </a:txBody>
                   <a:tcPr/>
                 </a:tc>
-                <a:extLst>
-                  <a:ext uri="{0D108BD9-81ED-4DB2-BD59-A6C34878D82A}">
-                    <a16:rowId xmlns:a16="http://schemas.microsoft.com/office/drawing/2014/main" val="10004"/>
-                  </a:ext>
-                </a:extLst>
-              </a:tr>
-              <a:tr h="365760">
-                <a:tc>
-                  <a:txBody>
-                    <a:bodyPr/>
-                    <a:lstStyle/>
-                    <a:p>
-                      <a:pPr algn="l">
-                        <a:defRPr sz="1100">
-                          <a:solidFill>
-                            <a:srgbClr val="1E293B"/>
-                          </a:solidFill>
-                        </a:defRPr>
-                      </a:pPr>
-                      <a:r>
-                        <a:t>GOOG</a:t>
-                      </a:r>
-                    </a:p>
-                  </a:txBody>
-                  <a:tcPr/>
-                </a:tc>
-                <a:tc>
-                  <a:txBody>
-                    <a:bodyPr/>
-                    <a:lstStyle/>
-                    <a:p>
-                      <a:pPr algn="l">
-                        <a:defRPr sz="1100">
-                          <a:solidFill>
-                            <a:srgbClr val="1E293B"/>
-                          </a:solidFill>
-                        </a:defRPr>
-                      </a:pPr>
-                      <a:r>
-                        <a:t>0.00%</a:t>
-                      </a:r>
-                    </a:p>
-                  </a:txBody>
-                  <a:tcPr/>
-                </a:tc>
-                <a:tc>
-                  <a:txBody>
-                    <a:bodyPr/>
-                    <a:lstStyle/>
-                    <a:p>
-                      <a:pPr algn="l">
-                        <a:defRPr sz="1100">
-                          <a:solidFill>
-                            <a:srgbClr val="1E293B"/>
-                          </a:solidFill>
-                        </a:defRPr>
-                      </a:pPr>
-                      <a:r>
-                        <a:t>0.00%</a:t>
-                      </a:r>
-                    </a:p>
-                  </a:txBody>
-                  <a:tcPr/>
-                </a:tc>
-                <a:tc>
-                  <a:txBody>
-                    <a:bodyPr/>
-                    <a:lstStyle/>
-                    <a:p>
-                      <a:pPr algn="l">
-                        <a:defRPr sz="1100">
-                          <a:solidFill>
-                            <a:srgbClr val="1E293B"/>
-                          </a:solidFill>
-                        </a:defRPr>
-                      </a:pPr>
-                      <a:r>
-                        <a:t>0.00</a:t>
-                      </a:r>
-                    </a:p>
-                  </a:txBody>
-                  <a:tcPr/>
-                </a:tc>
-                <a:tc>
-                  <a:txBody>
-                    <a:bodyPr/>
-                    <a:lstStyle/>
-                    <a:p>
-                      <a:pPr algn="l">
-                        <a:defRPr sz="1100">
-                          <a:solidFill>
-                            <a:srgbClr val="1E293B"/>
-                          </a:solidFill>
-                        </a:defRPr>
-                      </a:pPr>
-                      <a:r>
-                        <a:t>0.00%</a:t>
-                      </a:r>
-                    </a:p>
-                  </a:txBody>
-                  <a:tcPr/>
-                </a:tc>
-                <a:tc>
-                  <a:txBody>
-                    <a:bodyPr/>
-                    <a:lstStyle/>
-                    <a:p>
-                      <a:pPr algn="l">
-                        <a:defRPr sz="1100">
-                          <a:solidFill>
-                            <a:srgbClr val="1E293B"/>
-                          </a:solidFill>
-                        </a:defRPr>
-                      </a:pPr>
-                      <a:r>
-                        <a:t>0.75</a:t>
-                      </a:r>
-                    </a:p>
-                  </a:txBody>
-                  <a:tcPr/>
-                </a:tc>
-                <a:extLst>
-                  <a:ext uri="{0D108BD9-81ED-4DB2-BD59-A6C34878D82A}">
-                    <a16:rowId xmlns:a16="http://schemas.microsoft.com/office/drawing/2014/main" val="10005"/>
-                  </a:ext>
-                </a:extLst>
               </a:tr>
             </a:tbl>
           </a:graphicData>
@@ -4106,7 +3884,7 @@
 </file>
 
 <file path=ppt/slides/slide3.xml><?xml version="1.0" encoding="utf-8"?>
-<p:sld xmlns:a="http://schemas.openxmlformats.org/drawingml/2006/main" xmlns:r="http://schemas.openxmlformats.org/officeDocument/2006/relationships" xmlns:p="http://schemas.openxmlformats.org/presentationml/2006/main">
+<p:sld xmlns:a="http://schemas.openxmlformats.org/drawingml/2006/main" xmlns:p="http://schemas.openxmlformats.org/presentationml/2006/main" xmlns:r="http://schemas.openxmlformats.org/officeDocument/2006/relationships">
   <p:cSld>
     <p:spTree>
       <p:nvGrpSpPr>
@@ -4114,14 +3892,7 @@
         <p:cNvGrpSpPr/>
         <p:nvPr/>
       </p:nvGrpSpPr>
-      <p:grpSpPr>
-        <a:xfrm>
-          <a:off x="0" y="0"/>
-          <a:ext cx="0" cy="0"/>
-          <a:chOff x="0" y="0"/>
-          <a:chExt cx="0" cy="0"/>
-        </a:xfrm>
-      </p:grpSpPr>
+      <p:grpSpPr/>
       <p:sp>
         <p:nvSpPr>
           <p:cNvPr id="2" name="TextBox 1"/>
@@ -4152,7 +3923,7 @@
               </a:defRPr>
             </a:pPr>
             <a:r>
-              <a:t>Execution Performance Stream: META</a:t>
+              <a:t>Execution Performance Stream: CMCI</a:t>
             </a:r>
           </a:p>
         </p:txBody>
@@ -4192,9 +3963,97 @@
           </a:p>
         </p:txBody>
       </p:sp>
+    </p:spTree>
+  </p:cSld>
+  <p:clrMapOvr>
+    <a:masterClrMapping/>
+  </p:clrMapOvr>
+</p:sld>
+</file>
+
+<file path=ppt/slides/slide4.xml><?xml version="1.0" encoding="utf-8"?>
+<p:sld xmlns:a="http://schemas.openxmlformats.org/drawingml/2006/main" xmlns:p="http://schemas.openxmlformats.org/presentationml/2006/main" xmlns:r="http://schemas.openxmlformats.org/officeDocument/2006/relationships">
+  <p:cSld>
+    <p:spTree>
+      <p:nvGrpSpPr>
+        <p:cNvPr id="1" name=""/>
+        <p:cNvGrpSpPr/>
+        <p:nvPr/>
+      </p:nvGrpSpPr>
+      <p:grpSpPr/>
+      <p:sp>
+        <p:nvSpPr>
+          <p:cNvPr id="2" name="TextBox 1"/>
+          <p:cNvSpPr txBox="1"/>
+          <p:nvPr/>
+        </p:nvSpPr>
+        <p:spPr>
+          <a:xfrm>
+            <a:off x="685800" y="365760"/>
+            <a:ext cx="10820095" cy="548640"/>
+          </a:xfrm>
+          <a:prstGeom prst="rect">
+            <a:avLst/>
+          </a:prstGeom>
+          <a:noFill/>
+        </p:spPr>
+        <p:txBody>
+          <a:bodyPr wrap="none">
+            <a:spAutoFit/>
+          </a:bodyPr>
+          <a:lstStyle/>
+          <a:p>
+            <a:pPr>
+              <a:defRPr sz="2000" b="1">
+                <a:solidFill>
+                  <a:srgbClr val="0284C7"/>
+                </a:solidFill>
+              </a:defRPr>
+            </a:pPr>
+            <a:r>
+              <a:t>Execution Performance Stream: BGLD</a:t>
+            </a:r>
+          </a:p>
+        </p:txBody>
+      </p:sp>
+      <p:sp>
+        <p:nvSpPr>
+          <p:cNvPr id="3" name="TextBox 2"/>
+          <p:cNvSpPr txBox="1"/>
+          <p:nvPr/>
+        </p:nvSpPr>
+        <p:spPr>
+          <a:xfrm>
+            <a:off x="685800" y="914400"/>
+            <a:ext cx="10820095" cy="457200"/>
+          </a:xfrm>
+          <a:prstGeom prst="rect">
+            <a:avLst/>
+          </a:prstGeom>
+          <a:noFill/>
+        </p:spPr>
+        <p:txBody>
+          <a:bodyPr wrap="none">
+            <a:spAutoFit/>
+          </a:bodyPr>
+          <a:lstStyle/>
+          <a:p>
+            <a:pPr>
+              <a:defRPr sz="1100">
+                <a:solidFill>
+                  <a:srgbClr val="64748B"/>
+                </a:solidFill>
+              </a:defRPr>
+            </a:pPr>
+            <a:r>
+              <a:t>Executed Sells: 0 | Overnight Liquidations: 0 | Rejected via MA20: 0 | Rejected via Cost Basis: 0</a:t>
+            </a:r>
+          </a:p>
+        </p:txBody>
+      </p:sp>
       <p:pic>
         <p:nvPicPr>
-          <p:cNvPr id="4" name="Picture 3" descr="META_execution_topology.png"/>
+          <p:cNvPr id="4" name="Picture 3" descr="BGLD_execution_topology.png"/>
           <p:cNvPicPr>
             <a:picLocks noChangeAspect="1"/>
           </p:cNvPicPr>
@@ -4249,7 +4108,7 @@
       </p:sp>
       <p:pic>
         <p:nvPicPr>
-          <p:cNvPr id="6" name="Picture 5" descr="META_equity_curve.png"/>
+          <p:cNvPr id="6" name="Picture 5" descr="BGLD_equity_curve.png"/>
           <p:cNvPicPr>
             <a:picLocks noChangeAspect="1"/>
           </p:cNvPicPr>
@@ -4304,7 +4163,7 @@
       </p:sp>
       <p:pic>
         <p:nvPicPr>
-          <p:cNvPr id="8" name="Picture 7" descr="META_inventory_density.png"/>
+          <p:cNvPr id="8" name="Picture 7" descr="BGLD_inventory_density.png"/>
           <p:cNvPicPr>
             <a:picLocks noChangeAspect="1"/>
           </p:cNvPicPr>
@@ -4365,8 +4224,8 @@
 </p:sld>
 </file>
 
-<file path=ppt/slides/slide4.xml><?xml version="1.0" encoding="utf-8"?>
-<p:sld xmlns:a="http://schemas.openxmlformats.org/drawingml/2006/main" xmlns:r="http://schemas.openxmlformats.org/officeDocument/2006/relationships" xmlns:p="http://schemas.openxmlformats.org/presentationml/2006/main">
+<file path=ppt/slides/slide5.xml><?xml version="1.0" encoding="utf-8"?>
+<p:sld xmlns:a="http://schemas.openxmlformats.org/drawingml/2006/main" xmlns:p="http://schemas.openxmlformats.org/presentationml/2006/main" xmlns:r="http://schemas.openxmlformats.org/officeDocument/2006/relationships">
   <p:cSld>
     <p:spTree>
       <p:nvGrpSpPr>
@@ -4374,14 +4233,7 @@
         <p:cNvGrpSpPr/>
         <p:nvPr/>
       </p:nvGrpSpPr>
-      <p:grpSpPr>
-        <a:xfrm>
-          <a:off x="0" y="0"/>
-          <a:ext cx="0" cy="0"/>
-          <a:chOff x="0" y="0"/>
-          <a:chExt cx="0" cy="0"/>
-        </a:xfrm>
-      </p:grpSpPr>
+      <p:grpSpPr/>
       <p:sp>
         <p:nvSpPr>
           <p:cNvPr id="2" name="TextBox 1"/>
@@ -4412,7 +4264,7 @@
               </a:defRPr>
             </a:pPr>
             <a:r>
-              <a:t>Execution Performance Stream: SOXX</a:t>
+              <a:t>Execution Performance Stream: JEPQ</a:t>
             </a:r>
           </a:p>
         </p:txBody>
@@ -4454,7 +4306,7 @@
       </p:sp>
       <p:pic>
         <p:nvPicPr>
-          <p:cNvPr id="4" name="Picture 3" descr="SOXX_execution_topology.png"/>
+          <p:cNvPr id="4" name="Picture 3" descr="JEPQ_execution_topology.png"/>
           <p:cNvPicPr>
             <a:picLocks noChangeAspect="1"/>
           </p:cNvPicPr>
@@ -4509,7 +4361,7 @@
       </p:sp>
       <p:pic>
         <p:nvPicPr>
-          <p:cNvPr id="6" name="Picture 5" descr="SOXX_equity_curve.png"/>
+          <p:cNvPr id="6" name="Picture 5" descr="JEPQ_equity_curve.png"/>
           <p:cNvPicPr>
             <a:picLocks noChangeAspect="1"/>
           </p:cNvPicPr>
@@ -4564,7 +4416,7 @@
       </p:sp>
       <p:pic>
         <p:nvPicPr>
-          <p:cNvPr id="8" name="Picture 7" descr="SOXX_inventory_density.png"/>
+          <p:cNvPr id="8" name="Picture 7" descr="JEPQ_inventory_density.png"/>
           <p:cNvPicPr>
             <a:picLocks noChangeAspect="1"/>
           </p:cNvPicPr>
@@ -4625,8 +4477,8 @@
 </p:sld>
 </file>
 
-<file path=ppt/slides/slide5.xml><?xml version="1.0" encoding="utf-8"?>
-<p:sld xmlns:a="http://schemas.openxmlformats.org/drawingml/2006/main" xmlns:r="http://schemas.openxmlformats.org/officeDocument/2006/relationships" xmlns:p="http://schemas.openxmlformats.org/presentationml/2006/main">
+<file path=ppt/slides/slide6.xml><?xml version="1.0" encoding="utf-8"?>
+<p:sld xmlns:a="http://schemas.openxmlformats.org/drawingml/2006/main" xmlns:p="http://schemas.openxmlformats.org/presentationml/2006/main" xmlns:r="http://schemas.openxmlformats.org/officeDocument/2006/relationships">
   <p:cSld>
     <p:spTree>
       <p:nvGrpSpPr>
@@ -4634,14 +4486,7 @@
         <p:cNvGrpSpPr/>
         <p:nvPr/>
       </p:nvGrpSpPr>
-      <p:grpSpPr>
-        <a:xfrm>
-          <a:off x="0" y="0"/>
-          <a:ext cx="0" cy="0"/>
-          <a:chOff x="0" y="0"/>
-          <a:chExt cx="0" cy="0"/>
-        </a:xfrm>
-      </p:grpSpPr>
+      <p:grpSpPr/>
       <p:sp>
         <p:nvSpPr>
           <p:cNvPr id="2" name="TextBox 1"/>
@@ -4672,7 +4517,7 @@
               </a:defRPr>
             </a:pPr>
             <a:r>
-              <a:t>Execution Performance Stream: STT</a:t>
+              <a:t>Execution Performance Stream: QQQI</a:t>
             </a:r>
           </a:p>
         </p:txBody>
@@ -4714,7 +4559,7 @@
       </p:sp>
       <p:pic>
         <p:nvPicPr>
-          <p:cNvPr id="4" name="Picture 3" descr="STT_execution_topology.png"/>
+          <p:cNvPr id="4" name="Picture 3" descr="QQQI_execution_topology.png"/>
           <p:cNvPicPr>
             <a:picLocks noChangeAspect="1"/>
           </p:cNvPicPr>
@@ -4769,7 +4614,7 @@
       </p:sp>
       <p:pic>
         <p:nvPicPr>
-          <p:cNvPr id="6" name="Picture 5" descr="STT_equity_curve.png"/>
+          <p:cNvPr id="6" name="Picture 5" descr="QQQI_equity_curve.png"/>
           <p:cNvPicPr>
             <a:picLocks noChangeAspect="1"/>
           </p:cNvPicPr>
@@ -4824,527 +4669,7 @@
       </p:sp>
       <p:pic>
         <p:nvPicPr>
-          <p:cNvPr id="8" name="Picture 7" descr="STT_inventory_density.png"/>
-          <p:cNvPicPr>
-            <a:picLocks noChangeAspect="1"/>
-          </p:cNvPicPr>
-          <p:nvPr/>
-        </p:nvPicPr>
-        <p:blipFill>
-          <a:blip r:embed="rId4"/>
-          <a:stretch>
-            <a:fillRect/>
-          </a:stretch>
-        </p:blipFill>
-        <p:spPr>
-          <a:xfrm>
-            <a:off x="457200" y="4297680"/>
-            <a:ext cx="11277295" cy="1920240"/>
-          </a:xfrm>
-          <a:prstGeom prst="rect">
-            <a:avLst/>
-          </a:prstGeom>
-        </p:spPr>
-      </p:pic>
-      <p:sp>
-        <p:nvSpPr>
-          <p:cNvPr id="9" name="TextBox 8"/>
-          <p:cNvSpPr txBox="1"/>
-          <p:nvPr/>
-        </p:nvSpPr>
-        <p:spPr>
-          <a:xfrm>
-            <a:off x="457200" y="6217920"/>
-            <a:ext cx="11277295" cy="274320"/>
-          </a:xfrm>
-          <a:prstGeom prst="rect">
-            <a:avLst/>
-          </a:prstGeom>
-          <a:noFill/>
-        </p:spPr>
-        <p:txBody>
-          <a:bodyPr wrap="none">
-            <a:spAutoFit/>
-          </a:bodyPr>
-          <a:lstStyle/>
-          <a:p>
-            <a:pPr>
-              <a:defRPr sz="1000" i="1"/>
-            </a:pPr>
-            <a:r>
-              <a:t>Intraday Base Share Inventory Density Allocations</a:t>
-            </a:r>
-          </a:p>
-        </p:txBody>
-      </p:sp>
-    </p:spTree>
-  </p:cSld>
-  <p:clrMapOvr>
-    <a:masterClrMapping/>
-  </p:clrMapOvr>
-</p:sld>
-</file>
-
-<file path=ppt/slides/slide6.xml><?xml version="1.0" encoding="utf-8"?>
-<p:sld xmlns:a="http://schemas.openxmlformats.org/drawingml/2006/main" xmlns:r="http://schemas.openxmlformats.org/officeDocument/2006/relationships" xmlns:p="http://schemas.openxmlformats.org/presentationml/2006/main">
-  <p:cSld>
-    <p:spTree>
-      <p:nvGrpSpPr>
-        <p:cNvPr id="1" name=""/>
-        <p:cNvGrpSpPr/>
-        <p:nvPr/>
-      </p:nvGrpSpPr>
-      <p:grpSpPr>
-        <a:xfrm>
-          <a:off x="0" y="0"/>
-          <a:ext cx="0" cy="0"/>
-          <a:chOff x="0" y="0"/>
-          <a:chExt cx="0" cy="0"/>
-        </a:xfrm>
-      </p:grpSpPr>
-      <p:sp>
-        <p:nvSpPr>
-          <p:cNvPr id="2" name="TextBox 1"/>
-          <p:cNvSpPr txBox="1"/>
-          <p:nvPr/>
-        </p:nvSpPr>
-        <p:spPr>
-          <a:xfrm>
-            <a:off x="685800" y="365760"/>
-            <a:ext cx="10820095" cy="548640"/>
-          </a:xfrm>
-          <a:prstGeom prst="rect">
-            <a:avLst/>
-          </a:prstGeom>
-          <a:noFill/>
-        </p:spPr>
-        <p:txBody>
-          <a:bodyPr wrap="none">
-            <a:spAutoFit/>
-          </a:bodyPr>
-          <a:lstStyle/>
-          <a:p>
-            <a:pPr>
-              <a:defRPr sz="2000" b="1">
-                <a:solidFill>
-                  <a:srgbClr val="0284C7"/>
-                </a:solidFill>
-              </a:defRPr>
-            </a:pPr>
-            <a:r>
-              <a:t>Execution Performance Stream: MSFT</a:t>
-            </a:r>
-          </a:p>
-        </p:txBody>
-      </p:sp>
-      <p:sp>
-        <p:nvSpPr>
-          <p:cNvPr id="3" name="TextBox 2"/>
-          <p:cNvSpPr txBox="1"/>
-          <p:nvPr/>
-        </p:nvSpPr>
-        <p:spPr>
-          <a:xfrm>
-            <a:off x="685800" y="914400"/>
-            <a:ext cx="10820095" cy="457200"/>
-          </a:xfrm>
-          <a:prstGeom prst="rect">
-            <a:avLst/>
-          </a:prstGeom>
-          <a:noFill/>
-        </p:spPr>
-        <p:txBody>
-          <a:bodyPr wrap="none">
-            <a:spAutoFit/>
-          </a:bodyPr>
-          <a:lstStyle/>
-          <a:p>
-            <a:pPr>
-              <a:defRPr sz="1100">
-                <a:solidFill>
-                  <a:srgbClr val="64748B"/>
-                </a:solidFill>
-              </a:defRPr>
-            </a:pPr>
-            <a:r>
-              <a:t>Executed Sells: 0 | Overnight Liquidations: 0 | Rejected via MA20: 0 | Rejected via Cost Basis: 0</a:t>
-            </a:r>
-          </a:p>
-        </p:txBody>
-      </p:sp>
-      <p:pic>
-        <p:nvPicPr>
-          <p:cNvPr id="4" name="Picture 3" descr="MSFT_execution_topology.png"/>
-          <p:cNvPicPr>
-            <a:picLocks noChangeAspect="1"/>
-          </p:cNvPicPr>
-          <p:nvPr/>
-        </p:nvPicPr>
-        <p:blipFill>
-          <a:blip r:embed="rId2"/>
-          <a:stretch>
-            <a:fillRect/>
-          </a:stretch>
-        </p:blipFill>
-        <p:spPr>
-          <a:xfrm>
-            <a:off x="457200" y="1645920"/>
-            <a:ext cx="5486400" cy="2286000"/>
-          </a:xfrm>
-          <a:prstGeom prst="rect">
-            <a:avLst/>
-          </a:prstGeom>
-        </p:spPr>
-      </p:pic>
-      <p:sp>
-        <p:nvSpPr>
-          <p:cNvPr id="5" name="TextBox 4"/>
-          <p:cNvSpPr txBox="1"/>
-          <p:nvPr/>
-        </p:nvSpPr>
-        <p:spPr>
-          <a:xfrm>
-            <a:off x="457200" y="3931920"/>
-            <a:ext cx="5486400" cy="274320"/>
-          </a:xfrm>
-          <a:prstGeom prst="rect">
-            <a:avLst/>
-          </a:prstGeom>
-          <a:noFill/>
-        </p:spPr>
-        <p:txBody>
-          <a:bodyPr wrap="none">
-            <a:spAutoFit/>
-          </a:bodyPr>
-          <a:lstStyle/>
-          <a:p>
-            <a:pPr>
-              <a:defRPr sz="1000" i="1"/>
-            </a:pPr>
-            <a:r>
-              <a:t>Execution Strategy Topology Profiles</a:t>
-            </a:r>
-          </a:p>
-        </p:txBody>
-      </p:sp>
-      <p:pic>
-        <p:nvPicPr>
-          <p:cNvPr id="6" name="Picture 5" descr="MSFT_equity_curve.png"/>
-          <p:cNvPicPr>
-            <a:picLocks noChangeAspect="1"/>
-          </p:cNvPicPr>
-          <p:nvPr/>
-        </p:nvPicPr>
-        <p:blipFill>
-          <a:blip r:embed="rId3"/>
-          <a:stretch>
-            <a:fillRect/>
-          </a:stretch>
-        </p:blipFill>
-        <p:spPr>
-          <a:xfrm>
-            <a:off x="6248095" y="1645920"/>
-            <a:ext cx="5486400" cy="2286000"/>
-          </a:xfrm>
-          <a:prstGeom prst="rect">
-            <a:avLst/>
-          </a:prstGeom>
-        </p:spPr>
-      </p:pic>
-      <p:sp>
-        <p:nvSpPr>
-          <p:cNvPr id="7" name="TextBox 6"/>
-          <p:cNvSpPr txBox="1"/>
-          <p:nvPr/>
-        </p:nvSpPr>
-        <p:spPr>
-          <a:xfrm>
-            <a:off x="6248095" y="3931920"/>
-            <a:ext cx="5486400" cy="274320"/>
-          </a:xfrm>
-          <a:prstGeom prst="rect">
-            <a:avLst/>
-          </a:prstGeom>
-          <a:noFill/>
-        </p:spPr>
-        <p:txBody>
-          <a:bodyPr wrap="none">
-            <a:spAutoFit/>
-          </a:bodyPr>
-          <a:lstStyle/>
-          <a:p>
-            <a:pPr>
-              <a:defRPr sz="1000" i="1"/>
-            </a:pPr>
-            <a:r>
-              <a:t>Accumulated Growth Value Optimization</a:t>
-            </a:r>
-          </a:p>
-        </p:txBody>
-      </p:sp>
-      <p:pic>
-        <p:nvPicPr>
-          <p:cNvPr id="8" name="Picture 7" descr="MSFT_inventory_density.png"/>
-          <p:cNvPicPr>
-            <a:picLocks noChangeAspect="1"/>
-          </p:cNvPicPr>
-          <p:nvPr/>
-        </p:nvPicPr>
-        <p:blipFill>
-          <a:blip r:embed="rId4"/>
-          <a:stretch>
-            <a:fillRect/>
-          </a:stretch>
-        </p:blipFill>
-        <p:spPr>
-          <a:xfrm>
-            <a:off x="457200" y="4297680"/>
-            <a:ext cx="11277295" cy="1920240"/>
-          </a:xfrm>
-          <a:prstGeom prst="rect">
-            <a:avLst/>
-          </a:prstGeom>
-        </p:spPr>
-      </p:pic>
-      <p:sp>
-        <p:nvSpPr>
-          <p:cNvPr id="9" name="TextBox 8"/>
-          <p:cNvSpPr txBox="1"/>
-          <p:nvPr/>
-        </p:nvSpPr>
-        <p:spPr>
-          <a:xfrm>
-            <a:off x="457200" y="6217920"/>
-            <a:ext cx="11277295" cy="274320"/>
-          </a:xfrm>
-          <a:prstGeom prst="rect">
-            <a:avLst/>
-          </a:prstGeom>
-          <a:noFill/>
-        </p:spPr>
-        <p:txBody>
-          <a:bodyPr wrap="none">
-            <a:spAutoFit/>
-          </a:bodyPr>
-          <a:lstStyle/>
-          <a:p>
-            <a:pPr>
-              <a:defRPr sz="1000" i="1"/>
-            </a:pPr>
-            <a:r>
-              <a:t>Intraday Base Share Inventory Density Allocations</a:t>
-            </a:r>
-          </a:p>
-        </p:txBody>
-      </p:sp>
-    </p:spTree>
-  </p:cSld>
-  <p:clrMapOvr>
-    <a:masterClrMapping/>
-  </p:clrMapOvr>
-</p:sld>
-</file>
-
-<file path=ppt/slides/slide7.xml><?xml version="1.0" encoding="utf-8"?>
-<p:sld xmlns:a="http://schemas.openxmlformats.org/drawingml/2006/main" xmlns:r="http://schemas.openxmlformats.org/officeDocument/2006/relationships" xmlns:p="http://schemas.openxmlformats.org/presentationml/2006/main">
-  <p:cSld>
-    <p:spTree>
-      <p:nvGrpSpPr>
-        <p:cNvPr id="1" name=""/>
-        <p:cNvGrpSpPr/>
-        <p:nvPr/>
-      </p:nvGrpSpPr>
-      <p:grpSpPr>
-        <a:xfrm>
-          <a:off x="0" y="0"/>
-          <a:ext cx="0" cy="0"/>
-          <a:chOff x="0" y="0"/>
-          <a:chExt cx="0" cy="0"/>
-        </a:xfrm>
-      </p:grpSpPr>
-      <p:sp>
-        <p:nvSpPr>
-          <p:cNvPr id="2" name="TextBox 1"/>
-          <p:cNvSpPr txBox="1"/>
-          <p:nvPr/>
-        </p:nvSpPr>
-        <p:spPr>
-          <a:xfrm>
-            <a:off x="685800" y="365760"/>
-            <a:ext cx="10820095" cy="548640"/>
-          </a:xfrm>
-          <a:prstGeom prst="rect">
-            <a:avLst/>
-          </a:prstGeom>
-          <a:noFill/>
-        </p:spPr>
-        <p:txBody>
-          <a:bodyPr wrap="none">
-            <a:spAutoFit/>
-          </a:bodyPr>
-          <a:lstStyle/>
-          <a:p>
-            <a:pPr>
-              <a:defRPr sz="2000" b="1">
-                <a:solidFill>
-                  <a:srgbClr val="0284C7"/>
-                </a:solidFill>
-              </a:defRPr>
-            </a:pPr>
-            <a:r>
-              <a:t>Execution Performance Stream: GOOG</a:t>
-            </a:r>
-          </a:p>
-        </p:txBody>
-      </p:sp>
-      <p:sp>
-        <p:nvSpPr>
-          <p:cNvPr id="3" name="TextBox 2"/>
-          <p:cNvSpPr txBox="1"/>
-          <p:nvPr/>
-        </p:nvSpPr>
-        <p:spPr>
-          <a:xfrm>
-            <a:off x="685800" y="914400"/>
-            <a:ext cx="10820095" cy="457200"/>
-          </a:xfrm>
-          <a:prstGeom prst="rect">
-            <a:avLst/>
-          </a:prstGeom>
-          <a:noFill/>
-        </p:spPr>
-        <p:txBody>
-          <a:bodyPr wrap="none">
-            <a:spAutoFit/>
-          </a:bodyPr>
-          <a:lstStyle/>
-          <a:p>
-            <a:pPr>
-              <a:defRPr sz="1100">
-                <a:solidFill>
-                  <a:srgbClr val="64748B"/>
-                </a:solidFill>
-              </a:defRPr>
-            </a:pPr>
-            <a:r>
-              <a:t>Executed Sells: 0 | Overnight Liquidations: 0 | Rejected via MA20: 0 | Rejected via Cost Basis: 0</a:t>
-            </a:r>
-          </a:p>
-        </p:txBody>
-      </p:sp>
-      <p:pic>
-        <p:nvPicPr>
-          <p:cNvPr id="4" name="Picture 3" descr="GOOG_execution_topology.png"/>
-          <p:cNvPicPr>
-            <a:picLocks noChangeAspect="1"/>
-          </p:cNvPicPr>
-          <p:nvPr/>
-        </p:nvPicPr>
-        <p:blipFill>
-          <a:blip r:embed="rId2"/>
-          <a:stretch>
-            <a:fillRect/>
-          </a:stretch>
-        </p:blipFill>
-        <p:spPr>
-          <a:xfrm>
-            <a:off x="457200" y="1645920"/>
-            <a:ext cx="5486400" cy="2286000"/>
-          </a:xfrm>
-          <a:prstGeom prst="rect">
-            <a:avLst/>
-          </a:prstGeom>
-        </p:spPr>
-      </p:pic>
-      <p:sp>
-        <p:nvSpPr>
-          <p:cNvPr id="5" name="TextBox 4"/>
-          <p:cNvSpPr txBox="1"/>
-          <p:nvPr/>
-        </p:nvSpPr>
-        <p:spPr>
-          <a:xfrm>
-            <a:off x="457200" y="3931920"/>
-            <a:ext cx="5486400" cy="274320"/>
-          </a:xfrm>
-          <a:prstGeom prst="rect">
-            <a:avLst/>
-          </a:prstGeom>
-          <a:noFill/>
-        </p:spPr>
-        <p:txBody>
-          <a:bodyPr wrap="none">
-            <a:spAutoFit/>
-          </a:bodyPr>
-          <a:lstStyle/>
-          <a:p>
-            <a:pPr>
-              <a:defRPr sz="1000" i="1"/>
-            </a:pPr>
-            <a:r>
-              <a:t>Execution Strategy Topology Profiles</a:t>
-            </a:r>
-          </a:p>
-        </p:txBody>
-      </p:sp>
-      <p:pic>
-        <p:nvPicPr>
-          <p:cNvPr id="6" name="Picture 5" descr="GOOG_equity_curve.png"/>
-          <p:cNvPicPr>
-            <a:picLocks noChangeAspect="1"/>
-          </p:cNvPicPr>
-          <p:nvPr/>
-        </p:nvPicPr>
-        <p:blipFill>
-          <a:blip r:embed="rId3"/>
-          <a:stretch>
-            <a:fillRect/>
-          </a:stretch>
-        </p:blipFill>
-        <p:spPr>
-          <a:xfrm>
-            <a:off x="6248095" y="1645920"/>
-            <a:ext cx="5486400" cy="2286000"/>
-          </a:xfrm>
-          <a:prstGeom prst="rect">
-            <a:avLst/>
-          </a:prstGeom>
-        </p:spPr>
-      </p:pic>
-      <p:sp>
-        <p:nvSpPr>
-          <p:cNvPr id="7" name="TextBox 6"/>
-          <p:cNvSpPr txBox="1"/>
-          <p:nvPr/>
-        </p:nvSpPr>
-        <p:spPr>
-          <a:xfrm>
-            <a:off x="6248095" y="3931920"/>
-            <a:ext cx="5486400" cy="274320"/>
-          </a:xfrm>
-          <a:prstGeom prst="rect">
-            <a:avLst/>
-          </a:prstGeom>
-          <a:noFill/>
-        </p:spPr>
-        <p:txBody>
-          <a:bodyPr wrap="none">
-            <a:spAutoFit/>
-          </a:bodyPr>
-          <a:lstStyle/>
-          <a:p>
-            <a:pPr>
-              <a:defRPr sz="1000" i="1"/>
-            </a:pPr>
-            <a:r>
-              <a:t>Accumulated Growth Value Optimization</a:t>
-            </a:r>
-          </a:p>
-        </p:txBody>
-      </p:sp>
-      <p:pic>
-        <p:nvPicPr>
-          <p:cNvPr id="8" name="Picture 7" descr="GOOG_inventory_density.png"/>
+          <p:cNvPr id="8" name="Picture 7" descr="QQQI_inventory_density.png"/>
           <p:cNvPicPr>
             <a:picLocks noChangeAspect="1"/>
           </p:cNvPicPr>

</xml_diff>